<commit_message>
docs(apresentacao): slides 4, 6, 9 e 12 atualizados para a v2.0.0
So texto, editado direto nos XMLs do pacote (85 partes e imagens intactas;
152.045 -> 152.080 bytes); aberto e exportado no PowerPoint para conferir
que cabe nas caixas.

Co-Authored-By: Claude Opus 5.5 <noreply@anthropic.com>
</commit_message>
<xml_diff>
--- a/Apresentacao-Metodo-Norte.pptx
+++ b/Apresentacao-Metodo-Norte.pptx
@@ -3579,7 +3579,7 @@
                 <a:ea typeface="Calibri" pitchFamily="34" charset="-122"/>
                 <a:cs typeface="Calibri" pitchFamily="34" charset="-120"/>
               </a:rPr>
-              <a:t>Método Norte v1.3.0 · © 2026 Kasuo · Open-source (Licença MIT)</a:t>
+              <a:t>Método Norte v2.0.0 · © 2026 Kasuo · Open-source (Licença MIT)</a:t>
             </a:r>
             <a:endParaRPr lang="en-US" sz="1000" dirty="0"/>
           </a:p>
@@ -5233,7 +5233,7 @@
                 <a:ea typeface="Calibri" pitchFamily="34" charset="-122"/>
                 <a:cs typeface="Calibri" pitchFamily="34" charset="-120"/>
               </a:rPr>
-              <a:t>Qual sistema e que tipo de tarefa</a:t>
+              <a:t>Sistema e tarefa — a cada pedido</a:t>
             </a:r>
             <a:endParaRPr lang="en-US" sz="1150" dirty="0"/>
           </a:p>
@@ -5528,7 +5528,7 @@
                 <a:ea typeface="Calibri" pitchFamily="34" charset="-122"/>
                 <a:cs typeface="Calibri" pitchFamily="34" charset="-120"/>
               </a:rPr>
-              <a:t>Confirma o plano</a:t>
+              <a:t>Grava o plano</a:t>
             </a:r>
             <a:endParaRPr lang="en-US" sz="1500" dirty="0"/>
           </a:p>
@@ -5567,7 +5567,7 @@
                 <a:ea typeface="Calibri" pitchFamily="34" charset="-122"/>
                 <a:cs typeface="Calibri" pitchFamily="34" charset="-120"/>
               </a:rPr>
-              <a:t>Sistema, arquivos lidos, risco, ação</a:t>
+              <a:t>Passo 4 antes de editar (com trava)</a:t>
             </a:r>
             <a:endParaRPr lang="en-US" sz="1150" dirty="0"/>
           </a:p>
@@ -7271,7 +7271,7 @@
                 </a:solidFill>
                 <a:latin typeface="Calibri"/>
               </a:rPr>
-              <a:t>Onde o projeto está agora e o que falta — as pendências abertas, segurança em destaque. O relatório de 1 página que a IA lê e reporta ao abrir a sessão.</a:t>
+              <a:t>Onde o projeto está agora e o que falta — as pendências abertas, segurança em destaque. Ao abrir a sessão, a IA reporta em formato fixo: onde paramos, feito, falta ela, falta você.</a:t>
             </a:r>
           </a:p>
         </p:txBody>
@@ -7499,7 +7499,7 @@
                 </a:solidFill>
                 <a:latin typeface="Calibri"/>
               </a:rPr>
-              <a:t>Antes de tocar no código, a IA devolve um relatório: sistema, arquivos lidos, área impactada, risco e ação planejada. Você aprova antes.</a:t>
+              <a:t>Antes da 1ª edição de cada pedido, a IA grava e mostra: sistema, arquivos lidos, área, risco e plano. Com a trava, sem isso ela não edita.</a:t>
             </a:r>
           </a:p>
         </p:txBody>
@@ -8954,7 +8954,7 @@
                 <a:ea typeface="Calibri" pitchFamily="34" charset="-122"/>
                 <a:cs typeface="Calibri" pitchFamily="34" charset="-120"/>
               </a:rPr>
-              <a:t>17 arquivos com instruções de preenchimento passo a passo — hub, módulos, fichas, ADRs, progresso</a:t>
+              <a:t>26 arquivos com instruções passo a passo — hub, ciclo de 8 fases com decisões em cartão, módulos, ADRs, progresso</a:t>
             </a:r>
             <a:endParaRPr lang="en-US" sz="1150" dirty="0"/>
           </a:p>
@@ -9590,7 +9590,7 @@
                 <a:ea typeface="Calibri" pitchFamily="34" charset="-122"/>
                 <a:cs typeface="Calibri" pitchFamily="34" charset="-120"/>
               </a:rPr>
-              <a:t>Script que confere links, metadados e cobertura do índice — a doc não "mente"</a:t>
+              <a:t>Confere links e cobertura do índice + hooks opcionais que travam o que a IA esquece</a:t>
             </a:r>
             <a:endParaRPr lang="en-US" sz="1150" dirty="0"/>
           </a:p>

</xml_diff>